<commit_message>
Add final academic details (team names and college) for final submission
</commit_message>
<xml_diff>
--- a/LMSIS_Demo_Presentation.pptx
+++ b/LMSIS_Demo_Presentation.pptx
@@ -3383,13 +3383,13 @@
           <a:p>
             <a:pPr algn="ctr"/>
             <a:r>
-              <a:rPr sz="2000" b="0" i="0">
+              <a:rPr sz="1600" b="0" i="0">
                 <a:solidFill>
                   <a:srgbClr val="4A6380"/>
                 </a:solidFill>
                 <a:latin typeface="Inter"/>
               </a:rPr>
-              <a:t>[Presenter Name]</a:t>
+              <a:t>Karamjeet Singh (5244) • Sarandeep Singh (5244) • Ubaid Ahmad (5255) • Aiman Younus Dar (222176)</a:t>
             </a:r>
           </a:p>
         </p:txBody>
@@ -3402,7 +3402,7 @@
         </p:nvSpPr>
         <p:spPr>
           <a:xfrm>
-            <a:off x="975116" y="5029200"/>
+            <a:off x="975116" y="4937760"/>
             <a:ext cx="10238720" cy="457200"/>
           </a:xfrm>
           <a:prstGeom prst="rect">
@@ -3418,13 +3418,48 @@
           <a:p>
             <a:pPr algn="ctr"/>
             <a:r>
-              <a:rPr sz="2000" b="0" i="0">
+              <a:rPr sz="1800" b="0" i="0">
+                <a:solidFill>
+                  <a:srgbClr val="00C47D"/>
+                </a:solidFill>
+                <a:latin typeface="Inter"/>
+              </a:rPr>
+              <a:t>SHMM Government Degree College Anantnag</a:t>
+            </a:r>
+          </a:p>
+        </p:txBody>
+      </p:sp>
+      <p:sp>
+        <p:nvSpPr>
+          <p:cNvPr id="10" name="TextBox 9"/>
+          <p:cNvSpPr txBox="1"/>
+          <p:nvPr/>
+        </p:nvSpPr>
+        <p:spPr>
+          <a:xfrm>
+            <a:off x="975116" y="5303520"/>
+            <a:ext cx="10238720" cy="457200"/>
+          </a:xfrm>
+          <a:prstGeom prst="rect">
+            <a:avLst/>
+          </a:prstGeom>
+          <a:noFill/>
+        </p:spPr>
+        <p:txBody>
+          <a:bodyPr wrap="square">
+            <a:spAutoFit/>
+          </a:bodyPr>
+          <a:lstStyle/>
+          <a:p>
+            <a:pPr algn="ctr"/>
+            <a:r>
+              <a:rPr sz="1600" b="0" i="0">
                 <a:solidFill>
                   <a:srgbClr val="4A6380"/>
                 </a:solidFill>
                 <a:latin typeface="Inter"/>
               </a:rPr>
-              <a:t>[Date]</a:t>
+              <a:t>June 2026</a:t>
             </a:r>
           </a:p>
         </p:txBody>

</xml_diff>